<commit_message>
Rapport Boulanger 01.10-08.10 : ajout du panier moyen et de son évolution
Co-Authored-By: Claude Opus 5.5 <noreply@anthropic.com>
Claude-Session: https://claude.ai/code/session_018e7SCuQygFSJNrAfjS85j9
</commit_message>
<xml_diff>
--- a/rapports/In progress_20261009_Rapport_Boulanger_Hebdo_01.10-08.10 v2.pptx
+++ b/rapports/In progress_20261009_Rapport_Boulanger_Hebdo_01.10-08.10 v2.pptx
@@ -120,12 +120,12 @@
   <p:extLst>
     <p:ext uri="{521415D9-36F7-43E2-AB2F-B90AF26B5E84}">
       <p14:sectionLst xmlns:p14="http://schemas.microsoft.com/office/powerpoint/2010/main">
-        <p14:section name="Introduction" id="{336986a8-e577-a809-214b-257c771d299f}">
+        <p14:section name="Introduction" id="{3ec5d5d6-0ce6-86fd-31fb-8bcdf51dd82a}">
           <p14:sldIdLst>
             <p14:sldId id="256"/>
           </p14:sldIdLst>
         </p14:section>
-        <p14:section name="Boulanger" id="{d6b1e5b2-840f-05ce-8b55-39bdda3a2809}">
+        <p14:section name="Boulanger" id="{ff91e443-499b-0f3b-5cbd-f3cc4d7d314e}">
           <p14:sldIdLst>
             <p14:sldId id="257"/>
             <p14:sldId id="258"/>
@@ -138,7 +138,7 @@
             <p14:sldId id="265"/>
           </p14:sldIdLst>
         </p14:section>
-        <p14:section name="Pistes de reco" id="{4ebe84d1-b125-9f4d-279b-c1ddcf158dae}">
+        <p14:section name="Pistes de reco" id="{07233910-dba8-9b2c-6916-c3ed8cd40e4b}">
           <p14:sldIdLst>
             <p14:sldId id="266"/>
             <p14:sldId id="267"/>
@@ -7748,7 +7748,7 @@
         <p:spPr>
           <a:xfrm>
             <a:off x="548640" y="2057400"/>
-            <a:ext cx="1755648" cy="1371600"/>
+            <a:ext cx="1504188" cy="1371600"/>
           </a:xfrm>
           <a:prstGeom prst="roundRect">
             <a:avLst>
@@ -7775,7 +7775,7 @@
         <p:spPr>
           <a:xfrm>
             <a:off x="658368" y="2130552"/>
-            <a:ext cx="1536192" cy="329184"/>
+            <a:ext cx="1284732" cy="329184"/>
           </a:xfrm>
           <a:prstGeom prst="rect">
             <a:avLst/>
@@ -7811,7 +7811,7 @@
         <p:spPr>
           <a:xfrm>
             <a:off x="658368" y="2468880"/>
-            <a:ext cx="1536192" cy="411480"/>
+            <a:ext cx="1284732" cy="411480"/>
           </a:xfrm>
           <a:prstGeom prst="rect">
             <a:avLst/>
@@ -7827,14 +7827,14 @@
               <a:buNone/>
             </a:pPr>
             <a:r>
-              <a:rPr lang="en-US" sz="2000" b="1" dirty="0">
+              <a:rPr lang="en-US" sz="1800" b="1" dirty="0">
                 <a:solidFill>
                   <a:srgbClr val="1B2238"/>
                 </a:solidFill>
               </a:rPr>
               <a:t>1 311 465</a:t>
             </a:r>
-            <a:endParaRPr lang="en-US" sz="2000" dirty="0"/>
+            <a:endParaRPr lang="en-US" sz="1800" dirty="0"/>
           </a:p>
         </p:txBody>
       </p:sp>
@@ -7847,7 +7847,7 @@
         <p:spPr>
           <a:xfrm>
             <a:off x="658368" y="2880360"/>
-            <a:ext cx="1536192" cy="502920"/>
+            <a:ext cx="1284732" cy="502920"/>
           </a:xfrm>
           <a:prstGeom prst="rect">
             <a:avLst/>
@@ -7863,28 +7863,28 @@
               <a:buNone/>
             </a:pPr>
             <a:r>
-              <a:rPr lang="en-US" sz="1000" b="1" dirty="0">
+              <a:rPr lang="en-US" sz="900" b="1" dirty="0">
                 <a:solidFill>
                   <a:srgbClr val="2E9E6B"/>
                 </a:solidFill>
               </a:rPr>
               <a:t>▲ +16,7 %</a:t>
             </a:r>
-            <a:endParaRPr lang="en-US" sz="1000" dirty="0"/>
-          </a:p>
-          <a:p>
-            <a:pPr indent="0" marL="0">
-              <a:buNone/>
-            </a:pPr>
-            <a:r>
-              <a:rPr lang="en-US" sz="1000" dirty="0">
+            <a:endParaRPr lang="en-US" sz="900" dirty="0"/>
+          </a:p>
+          <a:p>
+            <a:pPr indent="0" marL="0">
+              <a:buNone/>
+            </a:pPr>
+            <a:r>
+              <a:rPr lang="en-US" sz="900" dirty="0">
                 <a:solidFill>
                   <a:srgbClr val="5A6275"/>
                 </a:solidFill>
               </a:rPr>
               <a:t>YTD 4 475 698</a:t>
             </a:r>
-            <a:endParaRPr lang="en-US" sz="1000" dirty="0"/>
+            <a:endParaRPr lang="en-US" sz="900" dirty="0"/>
           </a:p>
         </p:txBody>
       </p:sp>
@@ -7896,8 +7896,8 @@
         </p:nvSpPr>
         <p:spPr>
           <a:xfrm>
-            <a:off x="2410358" y="2057400"/>
-            <a:ext cx="1755648" cy="1371600"/>
+            <a:off x="2141525" y="2057400"/>
+            <a:ext cx="1504188" cy="1371600"/>
           </a:xfrm>
           <a:prstGeom prst="roundRect">
             <a:avLst>
@@ -7923,8 +7923,8 @@
         </p:nvSpPr>
         <p:spPr>
           <a:xfrm>
-            <a:off x="2520086" y="2130552"/>
-            <a:ext cx="1536192" cy="329184"/>
+            <a:off x="2251253" y="2130552"/>
+            <a:ext cx="1284732" cy="329184"/>
           </a:xfrm>
           <a:prstGeom prst="rect">
             <a:avLst/>
@@ -7959,8 +7959,8 @@
         </p:nvSpPr>
         <p:spPr>
           <a:xfrm>
-            <a:off x="2520086" y="2468880"/>
-            <a:ext cx="1536192" cy="411480"/>
+            <a:off x="2251253" y="2468880"/>
+            <a:ext cx="1284732" cy="411480"/>
           </a:xfrm>
           <a:prstGeom prst="rect">
             <a:avLst/>
@@ -7976,14 +7976,14 @@
               <a:buNone/>
             </a:pPr>
             <a:r>
-              <a:rPr lang="en-US" sz="2000" b="1" dirty="0">
+              <a:rPr lang="en-US" sz="1800" b="1" dirty="0">
                 <a:solidFill>
                   <a:srgbClr val="1B2238"/>
                 </a:solidFill>
               </a:rPr>
               <a:t>6 468</a:t>
             </a:r>
-            <a:endParaRPr lang="en-US" sz="2000" dirty="0"/>
+            <a:endParaRPr lang="en-US" sz="1800" dirty="0"/>
           </a:p>
         </p:txBody>
       </p:sp>
@@ -7995,8 +7995,8 @@
         </p:nvSpPr>
         <p:spPr>
           <a:xfrm>
-            <a:off x="2520086" y="2880360"/>
-            <a:ext cx="1536192" cy="502920"/>
+            <a:off x="2251253" y="2880360"/>
+            <a:ext cx="1284732" cy="502920"/>
           </a:xfrm>
           <a:prstGeom prst="rect">
             <a:avLst/>
@@ -8012,28 +8012,28 @@
               <a:buNone/>
             </a:pPr>
             <a:r>
-              <a:rPr lang="en-US" sz="1000" b="1" dirty="0">
+              <a:rPr lang="en-US" sz="900" b="1" dirty="0">
                 <a:solidFill>
                   <a:srgbClr val="C8372D"/>
                 </a:solidFill>
               </a:rPr>
               <a:t>▼ -11,3 %</a:t>
             </a:r>
-            <a:endParaRPr lang="en-US" sz="1000" dirty="0"/>
-          </a:p>
-          <a:p>
-            <a:pPr indent="0" marL="0">
-              <a:buNone/>
-            </a:pPr>
-            <a:r>
-              <a:rPr lang="en-US" sz="1000" dirty="0">
+            <a:endParaRPr lang="en-US" sz="900" dirty="0"/>
+          </a:p>
+          <a:p>
+            <a:pPr indent="0" marL="0">
+              <a:buNone/>
+            </a:pPr>
+            <a:r>
+              <a:rPr lang="en-US" sz="900" dirty="0">
                 <a:solidFill>
                   <a:srgbClr val="5A6275"/>
                 </a:solidFill>
               </a:rPr>
               <a:t>YTD 26 646</a:t>
             </a:r>
-            <a:endParaRPr lang="en-US" sz="1000" dirty="0"/>
+            <a:endParaRPr lang="en-US" sz="900" dirty="0"/>
           </a:p>
         </p:txBody>
       </p:sp>
@@ -8045,8 +8045,8 @@
         </p:nvSpPr>
         <p:spPr>
           <a:xfrm>
-            <a:off x="4272077" y="2057400"/>
-            <a:ext cx="1755648" cy="1371600"/>
+            <a:off x="3734410" y="2057400"/>
+            <a:ext cx="1504188" cy="1371600"/>
           </a:xfrm>
           <a:prstGeom prst="roundRect">
             <a:avLst>
@@ -8072,8 +8072,8 @@
         </p:nvSpPr>
         <p:spPr>
           <a:xfrm>
-            <a:off x="4381805" y="2130552"/>
-            <a:ext cx="1536192" cy="329184"/>
+            <a:off x="3844138" y="2130552"/>
+            <a:ext cx="1284732" cy="329184"/>
           </a:xfrm>
           <a:prstGeom prst="rect">
             <a:avLst/>
@@ -8108,8 +8108,8 @@
         </p:nvSpPr>
         <p:spPr>
           <a:xfrm>
-            <a:off x="4381805" y="2468880"/>
-            <a:ext cx="1536192" cy="411480"/>
+            <a:off x="3844138" y="2468880"/>
+            <a:ext cx="1284732" cy="411480"/>
           </a:xfrm>
           <a:prstGeom prst="rect">
             <a:avLst/>
@@ -8125,14 +8125,14 @@
               <a:buNone/>
             </a:pPr>
             <a:r>
-              <a:rPr lang="en-US" sz="2000" b="1" dirty="0">
+              <a:rPr lang="en-US" sz="1800" b="1" dirty="0">
                 <a:solidFill>
                   <a:srgbClr val="1B2238"/>
                 </a:solidFill>
               </a:rPr>
               <a:t>0,49 %</a:t>
             </a:r>
-            <a:endParaRPr lang="en-US" sz="2000" dirty="0"/>
+            <a:endParaRPr lang="en-US" sz="1800" dirty="0"/>
           </a:p>
         </p:txBody>
       </p:sp>
@@ -8144,8 +8144,8 @@
         </p:nvSpPr>
         <p:spPr>
           <a:xfrm>
-            <a:off x="4381805" y="2880360"/>
-            <a:ext cx="1536192" cy="502920"/>
+            <a:off x="3844138" y="2880360"/>
+            <a:ext cx="1284732" cy="502920"/>
           </a:xfrm>
           <a:prstGeom prst="rect">
             <a:avLst/>
@@ -8161,28 +8161,28 @@
               <a:buNone/>
             </a:pPr>
             <a:r>
-              <a:rPr lang="en-US" sz="1000" b="1" dirty="0">
+              <a:rPr lang="en-US" sz="900" b="1" dirty="0">
                 <a:solidFill>
                   <a:srgbClr val="C8372D"/>
                 </a:solidFill>
               </a:rPr>
               <a:t>▼ -0,16 pt</a:t>
             </a:r>
-            <a:endParaRPr lang="en-US" sz="1000" dirty="0"/>
-          </a:p>
-          <a:p>
-            <a:pPr indent="0" marL="0">
-              <a:buNone/>
-            </a:pPr>
-            <a:r>
-              <a:rPr lang="en-US" sz="1000" dirty="0">
+            <a:endParaRPr lang="en-US" sz="900" dirty="0"/>
+          </a:p>
+          <a:p>
+            <a:pPr indent="0" marL="0">
+              <a:buNone/>
+            </a:pPr>
+            <a:r>
+              <a:rPr lang="en-US" sz="900" dirty="0">
                 <a:solidFill>
                   <a:srgbClr val="5A6275"/>
                 </a:solidFill>
               </a:rPr>
               <a:t>YTD 0,60 %</a:t>
             </a:r>
-            <a:endParaRPr lang="en-US" sz="1000" dirty="0"/>
+            <a:endParaRPr lang="en-US" sz="900" dirty="0"/>
           </a:p>
         </p:txBody>
       </p:sp>
@@ -8194,8 +8194,8 @@
         </p:nvSpPr>
         <p:spPr>
           <a:xfrm>
-            <a:off x="6133795" y="2057400"/>
-            <a:ext cx="1755648" cy="1371600"/>
+            <a:off x="5327294" y="2057400"/>
+            <a:ext cx="1504188" cy="1371600"/>
           </a:xfrm>
           <a:prstGeom prst="roundRect">
             <a:avLst>
@@ -8221,8 +8221,8 @@
         </p:nvSpPr>
         <p:spPr>
           <a:xfrm>
-            <a:off x="6243523" y="2130552"/>
-            <a:ext cx="1536192" cy="329184"/>
+            <a:off x="5437022" y="2130552"/>
+            <a:ext cx="1284732" cy="329184"/>
           </a:xfrm>
           <a:prstGeom prst="rect">
             <a:avLst/>
@@ -8257,8 +8257,8 @@
         </p:nvSpPr>
         <p:spPr>
           <a:xfrm>
-            <a:off x="6243523" y="2468880"/>
-            <a:ext cx="1536192" cy="411480"/>
+            <a:off x="5437022" y="2468880"/>
+            <a:ext cx="1284732" cy="411480"/>
           </a:xfrm>
           <a:prstGeom prst="rect">
             <a:avLst/>
@@ -8274,14 +8274,14 @@
               <a:buNone/>
             </a:pPr>
             <a:r>
-              <a:rPr lang="en-US" sz="2000" b="1" dirty="0">
+              <a:rPr lang="en-US" sz="1800" b="1" dirty="0">
                 <a:solidFill>
                   <a:srgbClr val="1B2238"/>
                 </a:solidFill>
               </a:rPr>
               <a:t>0,37 €</a:t>
             </a:r>
-            <a:endParaRPr lang="en-US" sz="2000" dirty="0"/>
+            <a:endParaRPr lang="en-US" sz="1800" dirty="0"/>
           </a:p>
         </p:txBody>
       </p:sp>
@@ -8293,8 +8293,8 @@
         </p:nvSpPr>
         <p:spPr>
           <a:xfrm>
-            <a:off x="6243523" y="2880360"/>
-            <a:ext cx="1536192" cy="502920"/>
+            <a:off x="5437022" y="2880360"/>
+            <a:ext cx="1284732" cy="502920"/>
           </a:xfrm>
           <a:prstGeom prst="rect">
             <a:avLst/>
@@ -8310,28 +8310,28 @@
               <a:buNone/>
             </a:pPr>
             <a:r>
-              <a:rPr lang="en-US" sz="1000" b="1" dirty="0">
+              <a:rPr lang="en-US" sz="900" b="1" dirty="0">
                 <a:solidFill>
                   <a:srgbClr val="C8372D"/>
                 </a:solidFill>
               </a:rPr>
               <a:t>▲ +26,6 %</a:t>
             </a:r>
-            <a:endParaRPr lang="en-US" sz="1000" dirty="0"/>
-          </a:p>
-          <a:p>
-            <a:pPr indent="0" marL="0">
-              <a:buNone/>
-            </a:pPr>
-            <a:r>
-              <a:rPr lang="en-US" sz="1000" dirty="0">
+            <a:endParaRPr lang="en-US" sz="900" dirty="0"/>
+          </a:p>
+          <a:p>
+            <a:pPr indent="0" marL="0">
+              <a:buNone/>
+            </a:pPr>
+            <a:r>
+              <a:rPr lang="en-US" sz="900" dirty="0">
                 <a:solidFill>
                   <a:srgbClr val="5A6275"/>
                 </a:solidFill>
               </a:rPr>
               <a:t>YTD 0,27 €</a:t>
             </a:r>
-            <a:endParaRPr lang="en-US" sz="1000" dirty="0"/>
+            <a:endParaRPr lang="en-US" sz="900" dirty="0"/>
           </a:p>
         </p:txBody>
       </p:sp>
@@ -8343,8 +8343,8 @@
         </p:nvSpPr>
         <p:spPr>
           <a:xfrm>
-            <a:off x="7995514" y="2057400"/>
-            <a:ext cx="1755648" cy="1371600"/>
+            <a:off x="6920179" y="2057400"/>
+            <a:ext cx="1504188" cy="1371600"/>
           </a:xfrm>
           <a:prstGeom prst="roundRect">
             <a:avLst>
@@ -8370,8 +8370,8 @@
         </p:nvSpPr>
         <p:spPr>
           <a:xfrm>
-            <a:off x="8105242" y="2130552"/>
-            <a:ext cx="1536192" cy="329184"/>
+            <a:off x="7029907" y="2130552"/>
+            <a:ext cx="1284732" cy="329184"/>
           </a:xfrm>
           <a:prstGeom prst="rect">
             <a:avLst/>
@@ -8406,8 +8406,8 @@
         </p:nvSpPr>
         <p:spPr>
           <a:xfrm>
-            <a:off x="8105242" y="2468880"/>
-            <a:ext cx="1536192" cy="411480"/>
+            <a:off x="7029907" y="2468880"/>
+            <a:ext cx="1284732" cy="411480"/>
           </a:xfrm>
           <a:prstGeom prst="rect">
             <a:avLst/>
@@ -8423,14 +8423,14 @@
               <a:buNone/>
             </a:pPr>
             <a:r>
-              <a:rPr lang="en-US" sz="2000" b="1" dirty="0">
+              <a:rPr lang="en-US" sz="1800" b="1" dirty="0">
                 <a:solidFill>
                   <a:srgbClr val="1B2238"/>
                 </a:solidFill>
               </a:rPr>
               <a:t>6</a:t>
             </a:r>
-            <a:endParaRPr lang="en-US" sz="2000" dirty="0"/>
+            <a:endParaRPr lang="en-US" sz="1800" dirty="0"/>
           </a:p>
         </p:txBody>
       </p:sp>
@@ -8442,8 +8442,8 @@
         </p:nvSpPr>
         <p:spPr>
           <a:xfrm>
-            <a:off x="8105242" y="2880360"/>
-            <a:ext cx="1536192" cy="502920"/>
+            <a:off x="7029907" y="2880360"/>
+            <a:ext cx="1284732" cy="502920"/>
           </a:xfrm>
           <a:prstGeom prst="rect">
             <a:avLst/>
@@ -8459,28 +8459,28 @@
               <a:buNone/>
             </a:pPr>
             <a:r>
-              <a:rPr lang="en-US" sz="1000" b="1" dirty="0">
+              <a:rPr lang="en-US" sz="900" b="1" dirty="0">
                 <a:solidFill>
                   <a:srgbClr val="2E9E6B"/>
                 </a:solidFill>
               </a:rPr>
               <a:t>▲ +100 % (3)</a:t>
             </a:r>
-            <a:endParaRPr lang="en-US" sz="1000" dirty="0"/>
-          </a:p>
-          <a:p>
-            <a:pPr indent="0" marL="0">
-              <a:buNone/>
-            </a:pPr>
-            <a:r>
-              <a:rPr lang="en-US" sz="1000" dirty="0">
+            <a:endParaRPr lang="en-US" sz="900" dirty="0"/>
+          </a:p>
+          <a:p>
+            <a:pPr indent="0" marL="0">
+              <a:buNone/>
+            </a:pPr>
+            <a:r>
+              <a:rPr lang="en-US" sz="900" dirty="0">
                 <a:solidFill>
                   <a:srgbClr val="5A6275"/>
                 </a:solidFill>
               </a:rPr>
               <a:t>YTD 15</a:t>
             </a:r>
-            <a:endParaRPr lang="en-US" sz="1000" dirty="0"/>
+            <a:endParaRPr lang="en-US" sz="900" dirty="0"/>
           </a:p>
         </p:txBody>
       </p:sp>
@@ -8492,8 +8492,8 @@
         </p:nvSpPr>
         <p:spPr>
           <a:xfrm>
-            <a:off x="9857232" y="2057400"/>
-            <a:ext cx="1755648" cy="1371600"/>
+            <a:off x="8513064" y="2057400"/>
+            <a:ext cx="1504188" cy="1371600"/>
           </a:xfrm>
           <a:prstGeom prst="roundRect">
             <a:avLst>
@@ -8519,8 +8519,8 @@
         </p:nvSpPr>
         <p:spPr>
           <a:xfrm>
-            <a:off x="9966960" y="2130552"/>
-            <a:ext cx="1536192" cy="329184"/>
+            <a:off x="8622792" y="2130552"/>
+            <a:ext cx="1284732" cy="329184"/>
           </a:xfrm>
           <a:prstGeom prst="rect">
             <a:avLst/>
@@ -8555,8 +8555,8 @@
         </p:nvSpPr>
         <p:spPr>
           <a:xfrm>
-            <a:off x="9966960" y="2468880"/>
-            <a:ext cx="1536192" cy="411480"/>
+            <a:off x="8622792" y="2468880"/>
+            <a:ext cx="1284732" cy="411480"/>
           </a:xfrm>
           <a:prstGeom prst="rect">
             <a:avLst/>
@@ -8572,14 +8572,14 @@
               <a:buNone/>
             </a:pPr>
             <a:r>
-              <a:rPr lang="en-US" sz="2000" b="1" dirty="0">
+              <a:rPr lang="en-US" sz="1800" b="1" dirty="0">
                 <a:solidFill>
                   <a:srgbClr val="1B2238"/>
                 </a:solidFill>
               </a:rPr>
               <a:t>0,29 %</a:t>
             </a:r>
-            <a:endParaRPr lang="en-US" sz="2000" dirty="0"/>
+            <a:endParaRPr lang="en-US" sz="1800" dirty="0"/>
           </a:p>
         </p:txBody>
       </p:sp>
@@ -8591,8 +8591,8 @@
         </p:nvSpPr>
         <p:spPr>
           <a:xfrm>
-            <a:off x="9966960" y="2880360"/>
-            <a:ext cx="1536192" cy="502920"/>
+            <a:off x="8622792" y="2880360"/>
+            <a:ext cx="1284732" cy="502920"/>
           </a:xfrm>
           <a:prstGeom prst="rect">
             <a:avLst/>
@@ -8608,81 +8608,45 @@
               <a:buNone/>
             </a:pPr>
             <a:r>
-              <a:rPr lang="en-US" sz="1000" b="1" dirty="0">
+              <a:rPr lang="en-US" sz="900" b="1" dirty="0">
                 <a:solidFill>
                   <a:srgbClr val="2E9E6B"/>
                 </a:solidFill>
               </a:rPr>
               <a:t>▲ +0,17 pt</a:t>
             </a:r>
-            <a:endParaRPr lang="en-US" sz="1000" dirty="0"/>
-          </a:p>
-          <a:p>
-            <a:pPr indent="0" marL="0">
-              <a:buNone/>
-            </a:pPr>
-            <a:r>
-              <a:rPr lang="en-US" sz="1000" dirty="0">
+            <a:endParaRPr lang="en-US" sz="900" dirty="0"/>
+          </a:p>
+          <a:p>
+            <a:pPr indent="0" marL="0">
+              <a:buNone/>
+            </a:pPr>
+            <a:r>
+              <a:rPr lang="en-US" sz="900" dirty="0">
                 <a:solidFill>
                   <a:srgbClr val="5A6275"/>
                 </a:solidFill>
               </a:rPr>
               <a:t>YTD 0,20 %</a:t>
             </a:r>
-            <a:endParaRPr lang="en-US" sz="1000" dirty="0"/>
-          </a:p>
-        </p:txBody>
-      </p:sp>
-      <p:sp>
-        <p:nvSpPr>
-          <p:cNvPr id="30" name="Text 28"/>
-          <p:cNvSpPr txBox="1"/>
-          <p:nvPr/>
-        </p:nvSpPr>
-        <p:spPr>
-          <a:xfrm>
-            <a:off x="548640" y="3566160"/>
-            <a:ext cx="5486400" cy="274320"/>
-          </a:xfrm>
-          <a:prstGeom prst="rect">
-            <a:avLst/>
-          </a:prstGeom>
-          <a:noFill/>
-          <a:ln/>
-        </p:spPr>
-        <p:txBody>
-          <a:bodyPr wrap="square" lIns="0" tIns="0" rIns="0" bIns="0" rtlCol="0" anchor="ctr"/>
-          <a:lstStyle/>
-          <a:p>
-            <a:pPr indent="0" marL="0">
-              <a:buNone/>
-            </a:pPr>
-            <a:r>
-              <a:rPr lang="en-US" sz="1200" b="1" dirty="0">
-                <a:solidFill>
-                  <a:srgbClr val="E8601C"/>
-                </a:solidFill>
-              </a:rPr>
-              <a:t>VISIBILITÉ DANS LES RÉPONSES DE L'IA</a:t>
-            </a:r>
-            <a:endParaRPr lang="en-US" sz="1200" dirty="0"/>
-          </a:p>
-        </p:txBody>
-      </p:sp>
-      <p:sp>
-        <p:nvSpPr>
-          <p:cNvPr id="31" name="Shape 29"/>
+            <a:endParaRPr lang="en-US" sz="900" dirty="0"/>
+          </a:p>
+        </p:txBody>
+      </p:sp>
+      <p:sp>
+        <p:nvSpPr>
+          <p:cNvPr id="30" name="Shape 28"/>
           <p:cNvSpPr/>
           <p:nvPr/>
         </p:nvSpPr>
         <p:spPr>
           <a:xfrm>
-            <a:off x="548640" y="3886200"/>
-            <a:ext cx="2651760" cy="1417320"/>
+            <a:off x="10105949" y="2057400"/>
+            <a:ext cx="1504188" cy="1371600"/>
           </a:xfrm>
           <a:prstGeom prst="roundRect">
             <a:avLst>
-              <a:gd name="adj" fmla="val 6452"/>
+              <a:gd name="adj" fmla="val 5333"/>
             </a:avLst>
           </a:prstGeom>
           <a:solidFill>
@@ -8698,14 +8662,50 @@
       </p:sp>
       <p:sp>
         <p:nvSpPr>
+          <p:cNvPr id="31" name="Text 29"/>
+          <p:cNvSpPr txBox="1"/>
+          <p:nvPr/>
+        </p:nvSpPr>
+        <p:spPr>
+          <a:xfrm>
+            <a:off x="10215677" y="2130552"/>
+            <a:ext cx="1284732" cy="329184"/>
+          </a:xfrm>
+          <a:prstGeom prst="rect">
+            <a:avLst/>
+          </a:prstGeom>
+          <a:noFill/>
+          <a:ln/>
+        </p:spPr>
+        <p:txBody>
+          <a:bodyPr wrap="square" lIns="0" tIns="0" rIns="0" bIns="0" rtlCol="0" anchor="t"/>
+          <a:lstStyle/>
+          <a:p>
+            <a:pPr indent="0" marL="0">
+              <a:buNone/>
+            </a:pPr>
+            <a:r>
+              <a:rPr lang="en-US" sz="900" b="1" dirty="0">
+                <a:solidFill>
+                  <a:srgbClr val="5A6275"/>
+                </a:solidFill>
+              </a:rPr>
+              <a:t>PANIER MOYEN</a:t>
+            </a:r>
+            <a:endParaRPr lang="en-US" sz="900" dirty="0"/>
+          </a:p>
+        </p:txBody>
+      </p:sp>
+      <p:sp>
+        <p:nvSpPr>
           <p:cNvPr id="32" name="Text 30"/>
           <p:cNvSpPr txBox="1"/>
           <p:nvPr/>
         </p:nvSpPr>
         <p:spPr>
           <a:xfrm>
-            <a:off x="731520" y="3977640"/>
-            <a:ext cx="2286000" cy="274320"/>
+            <a:off x="10215677" y="2468880"/>
+            <a:ext cx="1284732" cy="411480"/>
           </a:xfrm>
           <a:prstGeom prst="rect">
             <a:avLst/>
@@ -8721,14 +8721,14 @@
               <a:buNone/>
             </a:pPr>
             <a:r>
-              <a:rPr lang="en-US" sz="1100" b="1" dirty="0">
-                <a:solidFill>
-                  <a:srgbClr val="5A6275"/>
-                </a:solidFill>
-              </a:rPr>
-              <a:t>SHARE OF VOICE GEO</a:t>
-            </a:r>
-            <a:endParaRPr lang="en-US" sz="1100" dirty="0"/>
+              <a:rPr lang="en-US" sz="1800" b="1" dirty="0">
+                <a:solidFill>
+                  <a:srgbClr val="1B2238"/>
+                </a:solidFill>
+              </a:rPr>
+              <a:t>148,11 €</a:t>
+            </a:r>
+            <a:endParaRPr lang="en-US" sz="1800" dirty="0"/>
           </a:p>
         </p:txBody>
       </p:sp>
@@ -8740,8 +8740,8 @@
         </p:nvSpPr>
         <p:spPr>
           <a:xfrm>
-            <a:off x="731520" y="4251960"/>
-            <a:ext cx="2286000" cy="548640"/>
+            <a:off x="10215677" y="2880360"/>
+            <a:ext cx="1284732" cy="502920"/>
           </a:xfrm>
           <a:prstGeom prst="rect">
             <a:avLst/>
@@ -8750,21 +8750,35 @@
           <a:ln/>
         </p:spPr>
         <p:txBody>
-          <a:bodyPr wrap="square" lIns="0" tIns="0" rIns="0" bIns="0" rtlCol="0" anchor="ctr"/>
-          <a:lstStyle/>
-          <a:p>
-            <a:pPr indent="0" marL="0">
-              <a:buNone/>
-            </a:pPr>
-            <a:r>
-              <a:rPr lang="en-US" sz="3000" b="1" dirty="0">
-                <a:solidFill>
-                  <a:srgbClr val="1B2238"/>
-                </a:solidFill>
-              </a:rPr>
-              <a:t>7,8 %</a:t>
-            </a:r>
-            <a:endParaRPr lang="en-US" sz="3000" dirty="0"/>
+          <a:bodyPr wrap="square" lIns="0" tIns="0" rIns="0" bIns="0" rtlCol="0" anchor="t"/>
+          <a:lstStyle/>
+          <a:p>
+            <a:pPr indent="0" marL="0">
+              <a:buNone/>
+            </a:pPr>
+            <a:r>
+              <a:rPr lang="en-US" sz="900" b="1" dirty="0">
+                <a:solidFill>
+                  <a:srgbClr val="2E9E6B"/>
+                </a:solidFill>
+              </a:rPr>
+              <a:t>▲ +4,2 %</a:t>
+            </a:r>
+            <a:endParaRPr lang="en-US" sz="900" dirty="0"/>
+          </a:p>
+          <a:p>
+            <a:pPr indent="0" marL="0">
+              <a:buNone/>
+            </a:pPr>
+            <a:r>
+              <a:rPr lang="en-US" sz="900" dirty="0">
+                <a:solidFill>
+                  <a:srgbClr val="5A6275"/>
+                </a:solidFill>
+              </a:rPr>
+              <a:t>vs 142,20 € · YTD 140,21 €</a:t>
+            </a:r>
+            <a:endParaRPr lang="en-US" sz="900" dirty="0"/>
           </a:p>
         </p:txBody>
       </p:sp>
@@ -8776,8 +8790,8 @@
         </p:nvSpPr>
         <p:spPr>
           <a:xfrm>
-            <a:off x="731520" y="4846320"/>
-            <a:ext cx="2286000" cy="320040"/>
+            <a:off x="548640" y="3566160"/>
+            <a:ext cx="5486400" cy="274320"/>
           </a:xfrm>
           <a:prstGeom prst="rect">
             <a:avLst/>
@@ -8795,10 +8809,10 @@
             <a:r>
               <a:rPr lang="en-US" sz="1200" b="1" dirty="0">
                 <a:solidFill>
-                  <a:srgbClr val="2E9E6B"/>
-                </a:solidFill>
-              </a:rPr>
-              <a:t>▲ +2,5 pts  vs 23/09 → 30/09</a:t>
+                  <a:srgbClr val="E8601C"/>
+                </a:solidFill>
+              </a:rPr>
+              <a:t>VISIBILITÉ DANS LES RÉPONSES DE L'IA</a:t>
             </a:r>
             <a:endParaRPr lang="en-US" sz="1200" dirty="0"/>
           </a:p>
@@ -8812,7 +8826,7 @@
         </p:nvSpPr>
         <p:spPr>
           <a:xfrm>
-            <a:off x="3353105" y="3886200"/>
+            <a:off x="548640" y="3886200"/>
             <a:ext cx="2651760" cy="1417320"/>
           </a:xfrm>
           <a:prstGeom prst="roundRect">
@@ -8839,7 +8853,7 @@
         </p:nvSpPr>
         <p:spPr>
           <a:xfrm>
-            <a:off x="3535985" y="3977640"/>
+            <a:off x="731520" y="3977640"/>
             <a:ext cx="2286000" cy="274320"/>
           </a:xfrm>
           <a:prstGeom prst="rect">
@@ -8861,7 +8875,7 @@
                   <a:srgbClr val="5A6275"/>
                 </a:solidFill>
               </a:rPr>
-              <a:t>SHARE OF VOICE GEA (ADS)</a:t>
+              <a:t>SHARE OF VOICE GEO</a:t>
             </a:r>
             <a:endParaRPr lang="en-US" sz="1100" dirty="0"/>
           </a:p>
@@ -8875,7 +8889,7 @@
         </p:nvSpPr>
         <p:spPr>
           <a:xfrm>
-            <a:off x="3535985" y="4251960"/>
+            <a:off x="731520" y="4251960"/>
             <a:ext cx="2286000" cy="548640"/>
           </a:xfrm>
           <a:prstGeom prst="rect">
@@ -8897,7 +8911,7 @@
                   <a:srgbClr val="1B2238"/>
                 </a:solidFill>
               </a:rPr>
-              <a:t>20,2 %</a:t>
+              <a:t>7,8 %</a:t>
             </a:r>
             <a:endParaRPr lang="en-US" sz="3000" dirty="0"/>
           </a:p>
@@ -8911,7 +8925,7 @@
         </p:nvSpPr>
         <p:spPr>
           <a:xfrm>
-            <a:off x="3535985" y="4846320"/>
+            <a:off x="731520" y="4846320"/>
             <a:ext cx="2286000" cy="320040"/>
           </a:xfrm>
           <a:prstGeom prst="rect">
@@ -8930,10 +8944,10 @@
             <a:r>
               <a:rPr lang="en-US" sz="1200" b="1" dirty="0">
                 <a:solidFill>
-                  <a:srgbClr val="C8372D"/>
-                </a:solidFill>
-              </a:rPr>
-              <a:t>▼ -2,8 pts  vs 23/09 → 30/09</a:t>
+                  <a:srgbClr val="2E9E6B"/>
+                </a:solidFill>
+              </a:rPr>
+              <a:t>▲ +2,5 pts  vs 23/09 → 30/09</a:t>
             </a:r>
             <a:endParaRPr lang="en-US" sz="1200" dirty="0"/>
           </a:p>
@@ -8947,7 +8961,7 @@
         </p:nvSpPr>
         <p:spPr>
           <a:xfrm>
-            <a:off x="6157570" y="3886200"/>
+            <a:off x="3353105" y="3886200"/>
             <a:ext cx="2651760" cy="1417320"/>
           </a:xfrm>
           <a:prstGeom prst="roundRect">
@@ -8974,7 +8988,7 @@
         </p:nvSpPr>
         <p:spPr>
           <a:xfrm>
-            <a:off x="6340450" y="3977640"/>
+            <a:off x="3535985" y="3977640"/>
             <a:ext cx="2286000" cy="274320"/>
           </a:xfrm>
           <a:prstGeom prst="rect">
@@ -8996,7 +9010,7 @@
                   <a:srgbClr val="5A6275"/>
                 </a:solidFill>
               </a:rPr>
-              <a:t>SHARE OF VOICE</a:t>
+              <a:t>SHARE OF VOICE GEA (ADS)</a:t>
             </a:r>
             <a:endParaRPr lang="en-US" sz="1100" dirty="0"/>
           </a:p>
@@ -9010,7 +9024,7 @@
         </p:nvSpPr>
         <p:spPr>
           <a:xfrm>
-            <a:off x="6340450" y="4251960"/>
+            <a:off x="3535985" y="4251960"/>
             <a:ext cx="2286000" cy="548640"/>
           </a:xfrm>
           <a:prstGeom prst="rect">
@@ -9032,7 +9046,7 @@
                   <a:srgbClr val="1B2238"/>
                 </a:solidFill>
               </a:rPr>
-              <a:t>4,3 %</a:t>
+              <a:t>20,2 %</a:t>
             </a:r>
             <a:endParaRPr lang="en-US" sz="3000" dirty="0"/>
           </a:p>
@@ -9046,7 +9060,7 @@
         </p:nvSpPr>
         <p:spPr>
           <a:xfrm>
-            <a:off x="6340450" y="4846320"/>
+            <a:off x="3535985" y="4846320"/>
             <a:ext cx="2286000" cy="320040"/>
           </a:xfrm>
           <a:prstGeom prst="rect">
@@ -9065,10 +9079,10 @@
             <a:r>
               <a:rPr lang="en-US" sz="1200" b="1" dirty="0">
                 <a:solidFill>
-                  <a:srgbClr val="2E9E6B"/>
-                </a:solidFill>
-              </a:rPr>
-              <a:t>▲ +0,3 pt  vs 23/09 → 30/09</a:t>
+                  <a:srgbClr val="C8372D"/>
+                </a:solidFill>
+              </a:rPr>
+              <a:t>▼ -2,8 pts  vs 23/09 → 30/09</a:t>
             </a:r>
             <a:endParaRPr lang="en-US" sz="1200" dirty="0"/>
           </a:p>
@@ -9082,7 +9096,7 @@
         </p:nvSpPr>
         <p:spPr>
           <a:xfrm>
-            <a:off x="8962034" y="3886200"/>
+            <a:off x="6157570" y="3886200"/>
             <a:ext cx="2651760" cy="1417320"/>
           </a:xfrm>
           <a:prstGeom prst="roundRect">
@@ -9109,7 +9123,7 @@
         </p:nvSpPr>
         <p:spPr>
           <a:xfrm>
-            <a:off x="9144914" y="3977640"/>
+            <a:off x="6340450" y="3977640"/>
             <a:ext cx="2286000" cy="274320"/>
           </a:xfrm>
           <a:prstGeom prst="rect">
@@ -9131,7 +9145,7 @@
                   <a:srgbClr val="5A6275"/>
                 </a:solidFill>
               </a:rPr>
-              <a:t>LONGUEUR DES REQUÊTES</a:t>
+              <a:t>SHARE OF VOICE</a:t>
             </a:r>
             <a:endParaRPr lang="en-US" sz="1100" dirty="0"/>
           </a:p>
@@ -9145,7 +9159,7 @@
         </p:nvSpPr>
         <p:spPr>
           <a:xfrm>
-            <a:off x="9144914" y="4251960"/>
+            <a:off x="6340450" y="4251960"/>
             <a:ext cx="2286000" cy="548640"/>
           </a:xfrm>
           <a:prstGeom prst="rect">
@@ -9167,7 +9181,7 @@
                   <a:srgbClr val="1B2238"/>
                 </a:solidFill>
               </a:rPr>
-              <a:t>8,2 mots</a:t>
+              <a:t>4,3 %</a:t>
             </a:r>
             <a:endParaRPr lang="en-US" sz="3000" dirty="0"/>
           </a:p>
@@ -9181,7 +9195,7 @@
         </p:nvSpPr>
         <p:spPr>
           <a:xfrm>
-            <a:off x="9144914" y="4846320"/>
+            <a:off x="6340450" y="4846320"/>
             <a:ext cx="2286000" cy="320040"/>
           </a:xfrm>
           <a:prstGeom prst="rect">
@@ -9203,7 +9217,7 @@
                   <a:srgbClr val="2E9E6B"/>
                 </a:solidFill>
               </a:rPr>
-              <a:t>▲ +10,6 %  vs 23/09 → 30/09</a:t>
+              <a:t>▲ +0,3 pt  vs 23/09 → 30/09</a:t>
             </a:r>
             <a:endParaRPr lang="en-US" sz="1200" dirty="0"/>
           </a:p>
@@ -9217,12 +9231,12 @@
         </p:nvSpPr>
         <p:spPr>
           <a:xfrm>
-            <a:off x="548640" y="5486400"/>
-            <a:ext cx="11064240" cy="566928"/>
+            <a:off x="8962034" y="3886200"/>
+            <a:ext cx="2651760" cy="1417320"/>
           </a:xfrm>
           <a:prstGeom prst="roundRect">
             <a:avLst>
-              <a:gd name="adj" fmla="val 12903"/>
+              <a:gd name="adj" fmla="val 6452"/>
             </a:avLst>
           </a:prstGeom>
           <a:solidFill>
@@ -9239,6 +9253,141 @@
       <p:sp>
         <p:nvSpPr>
           <p:cNvPr id="48" name="Text 46"/>
+          <p:cNvSpPr txBox="1"/>
+          <p:nvPr/>
+        </p:nvSpPr>
+        <p:spPr>
+          <a:xfrm>
+            <a:off x="9144914" y="3977640"/>
+            <a:ext cx="2286000" cy="274320"/>
+          </a:xfrm>
+          <a:prstGeom prst="rect">
+            <a:avLst/>
+          </a:prstGeom>
+          <a:noFill/>
+          <a:ln/>
+        </p:spPr>
+        <p:txBody>
+          <a:bodyPr wrap="square" lIns="0" tIns="0" rIns="0" bIns="0" rtlCol="0" anchor="ctr"/>
+          <a:lstStyle/>
+          <a:p>
+            <a:pPr indent="0" marL="0">
+              <a:buNone/>
+            </a:pPr>
+            <a:r>
+              <a:rPr lang="en-US" sz="1100" b="1" dirty="0">
+                <a:solidFill>
+                  <a:srgbClr val="5A6275"/>
+                </a:solidFill>
+              </a:rPr>
+              <a:t>LONGUEUR DES REQUÊTES</a:t>
+            </a:r>
+            <a:endParaRPr lang="en-US" sz="1100" dirty="0"/>
+          </a:p>
+        </p:txBody>
+      </p:sp>
+      <p:sp>
+        <p:nvSpPr>
+          <p:cNvPr id="49" name="Text 47"/>
+          <p:cNvSpPr txBox="1"/>
+          <p:nvPr/>
+        </p:nvSpPr>
+        <p:spPr>
+          <a:xfrm>
+            <a:off x="9144914" y="4251960"/>
+            <a:ext cx="2286000" cy="548640"/>
+          </a:xfrm>
+          <a:prstGeom prst="rect">
+            <a:avLst/>
+          </a:prstGeom>
+          <a:noFill/>
+          <a:ln/>
+        </p:spPr>
+        <p:txBody>
+          <a:bodyPr wrap="square" lIns="0" tIns="0" rIns="0" bIns="0" rtlCol="0" anchor="ctr"/>
+          <a:lstStyle/>
+          <a:p>
+            <a:pPr indent="0" marL="0">
+              <a:buNone/>
+            </a:pPr>
+            <a:r>
+              <a:rPr lang="en-US" sz="3000" b="1" dirty="0">
+                <a:solidFill>
+                  <a:srgbClr val="1B2238"/>
+                </a:solidFill>
+              </a:rPr>
+              <a:t>8,2 mots</a:t>
+            </a:r>
+            <a:endParaRPr lang="en-US" sz="3000" dirty="0"/>
+          </a:p>
+        </p:txBody>
+      </p:sp>
+      <p:sp>
+        <p:nvSpPr>
+          <p:cNvPr id="50" name="Text 48"/>
+          <p:cNvSpPr txBox="1"/>
+          <p:nvPr/>
+        </p:nvSpPr>
+        <p:spPr>
+          <a:xfrm>
+            <a:off x="9144914" y="4846320"/>
+            <a:ext cx="2286000" cy="320040"/>
+          </a:xfrm>
+          <a:prstGeom prst="rect">
+            <a:avLst/>
+          </a:prstGeom>
+          <a:noFill/>
+          <a:ln/>
+        </p:spPr>
+        <p:txBody>
+          <a:bodyPr wrap="square" lIns="0" tIns="0" rIns="0" bIns="0" rtlCol="0" anchor="ctr"/>
+          <a:lstStyle/>
+          <a:p>
+            <a:pPr indent="0" marL="0">
+              <a:buNone/>
+            </a:pPr>
+            <a:r>
+              <a:rPr lang="en-US" sz="1200" b="1" dirty="0">
+                <a:solidFill>
+                  <a:srgbClr val="2E9E6B"/>
+                </a:solidFill>
+              </a:rPr>
+              <a:t>▲ +10,6 %  vs 23/09 → 30/09</a:t>
+            </a:r>
+            <a:endParaRPr lang="en-US" sz="1200" dirty="0"/>
+          </a:p>
+        </p:txBody>
+      </p:sp>
+      <p:sp>
+        <p:nvSpPr>
+          <p:cNvPr id="51" name="Shape 49"/>
+          <p:cNvSpPr/>
+          <p:nvPr/>
+        </p:nvSpPr>
+        <p:spPr>
+          <a:xfrm>
+            <a:off x="548640" y="5486400"/>
+            <a:ext cx="11064240" cy="566928"/>
+          </a:xfrm>
+          <a:prstGeom prst="roundRect">
+            <a:avLst>
+              <a:gd name="adj" fmla="val 12903"/>
+            </a:avLst>
+          </a:prstGeom>
+          <a:solidFill>
+            <a:srgbClr val="F2F4F8"/>
+          </a:solidFill>
+          <a:ln w="12700">
+            <a:solidFill>
+              <a:srgbClr val="F2F4F8"/>
+            </a:solidFill>
+            <a:prstDash val="solid"/>
+          </a:ln>
+        </p:spPr>
+      </p:sp>
+      <p:sp>
+        <p:nvSpPr>
+          <p:cNvPr id="52" name="Text 50"/>
           <p:cNvSpPr txBox="1"/>
           <p:nvPr/>
         </p:nvSpPr>

</xml_diff>